<commit_message>
update lab 11 slides
</commit_message>
<xml_diff>
--- a/labs/11-1_CNN/Lab11-1.pptx
+++ b/labs/11-1_CNN/Lab11-1.pptx
@@ -5,7 +5,7 @@
     <p:sldMasterId id="2147483648" r:id="rId1"/>
   </p:sldMasterIdLst>
   <p:notesMasterIdLst>
-    <p:notesMasterId r:id="rId22"/>
+    <p:notesMasterId r:id="rId21"/>
   </p:notesMasterIdLst>
   <p:sldIdLst>
     <p:sldId id="256" r:id="rId2"/>
@@ -17,17 +17,16 @@
     <p:sldId id="296" r:id="rId8"/>
     <p:sldId id="297" r:id="rId9"/>
     <p:sldId id="267" r:id="rId10"/>
-    <p:sldId id="298" r:id="rId11"/>
-    <p:sldId id="299" r:id="rId12"/>
-    <p:sldId id="300" r:id="rId13"/>
-    <p:sldId id="276" r:id="rId14"/>
-    <p:sldId id="301" r:id="rId15"/>
-    <p:sldId id="302" r:id="rId16"/>
-    <p:sldId id="290" r:id="rId17"/>
-    <p:sldId id="303" r:id="rId18"/>
-    <p:sldId id="304" r:id="rId19"/>
-    <p:sldId id="305" r:id="rId20"/>
-    <p:sldId id="306" r:id="rId21"/>
+    <p:sldId id="299" r:id="rId11"/>
+    <p:sldId id="300" r:id="rId12"/>
+    <p:sldId id="276" r:id="rId13"/>
+    <p:sldId id="301" r:id="rId14"/>
+    <p:sldId id="302" r:id="rId15"/>
+    <p:sldId id="290" r:id="rId16"/>
+    <p:sldId id="303" r:id="rId17"/>
+    <p:sldId id="304" r:id="rId18"/>
+    <p:sldId id="305" r:id="rId19"/>
+    <p:sldId id="306" r:id="rId20"/>
   </p:sldIdLst>
   <p:sldSz cx="12192000" cy="6858000"/>
   <p:notesSz cx="12192000" cy="6858000"/>
@@ -696,7 +695,7 @@
           <a:p>
             <a:fld id="{D78BFFD5-ADB4-A64A-B2D5-082ABE10A18B}" type="slidenum">
               <a:rPr lang="en-TW" smtClean="0"/>
-              <a:t>14</a:t>
+              <a:t>13</a:t>
             </a:fld>
             <a:endParaRPr lang="en-TW"/>
           </a:p>
@@ -804,7 +803,7 @@
           <a:p>
             <a:fld id="{D78BFFD5-ADB4-A64A-B2D5-082ABE10A18B}" type="slidenum">
               <a:rPr lang="en-TW" smtClean="0"/>
-              <a:t>15</a:t>
+              <a:t>14</a:t>
             </a:fld>
             <a:endParaRPr lang="en-TW"/>
           </a:p>
@@ -888,7 +887,7 @@
           <a:p>
             <a:fld id="{D78BFFD5-ADB4-A64A-B2D5-082ABE10A18B}" type="slidenum">
               <a:rPr lang="en-TW" smtClean="0"/>
-              <a:t>17</a:t>
+              <a:t>16</a:t>
             </a:fld>
             <a:endParaRPr lang="en-TW"/>
           </a:p>
@@ -972,7 +971,7 @@
           <a:p>
             <a:fld id="{D78BFFD5-ADB4-A64A-B2D5-082ABE10A18B}" type="slidenum">
               <a:rPr lang="en-TW" smtClean="0"/>
-              <a:t>18</a:t>
+              <a:t>17</a:t>
             </a:fld>
             <a:endParaRPr lang="en-TW"/>
           </a:p>
@@ -1063,7 +1062,7 @@
           <a:p>
             <a:fld id="{D78BFFD5-ADB4-A64A-B2D5-082ABE10A18B}" type="slidenum">
               <a:rPr lang="en-TW" smtClean="0"/>
-              <a:t>19</a:t>
+              <a:t>18</a:t>
             </a:fld>
             <a:endParaRPr lang="en-TW"/>
           </a:p>
@@ -1233,7 +1232,7 @@
           <a:p>
             <a:fld id="{1D8BD707-D9CF-40AE-B4C6-C98DA3205C09}" type="datetimeFigureOut">
               <a:rPr lang="en-US"/>
-              <a:t>10/21/26</a:t>
+              <a:t>10/22/26</a:t>
             </a:fld>
             <a:endParaRPr lang="en-US"/>
           </a:p>
@@ -1410,7 +1409,7 @@
           <a:p>
             <a:fld id="{1D8BD707-D9CF-40AE-B4C6-C98DA3205C09}" type="datetimeFigureOut">
               <a:rPr lang="en-US"/>
-              <a:t>10/21/26</a:t>
+              <a:t>10/22/26</a:t>
             </a:fld>
             <a:endParaRPr lang="en-US"/>
           </a:p>
@@ -1624,7 +1623,7 @@
           <a:p>
             <a:fld id="{1D8BD707-D9CF-40AE-B4C6-C98DA3205C09}" type="datetimeFigureOut">
               <a:rPr lang="en-US"/>
-              <a:t>10/21/26</a:t>
+              <a:t>10/22/26</a:t>
             </a:fld>
             <a:endParaRPr lang="en-US"/>
           </a:p>
@@ -1772,7 +1771,7 @@
           <a:p>
             <a:fld id="{1D8BD707-D9CF-40AE-B4C6-C98DA3205C09}" type="datetimeFigureOut">
               <a:rPr lang="en-US"/>
-              <a:t>10/21/26</a:t>
+              <a:t>10/22/26</a:t>
             </a:fld>
             <a:endParaRPr lang="en-US"/>
           </a:p>
@@ -1891,7 +1890,7 @@
           <a:p>
             <a:fld id="{1D8BD707-D9CF-40AE-B4C6-C98DA3205C09}" type="datetimeFigureOut">
               <a:rPr lang="en-US"/>
-              <a:t>10/21/26</a:t>
+              <a:t>10/22/26</a:t>
             </a:fld>
             <a:endParaRPr lang="en-US"/>
           </a:p>
@@ -2116,7 +2115,7 @@
           <a:p>
             <a:fld id="{1D8BD707-D9CF-40AE-B4C6-C98DA3205C09}" type="datetimeFigureOut">
               <a:rPr lang="en-US"/>
-              <a:t>10/21/26</a:t>
+              <a:t>10/22/26</a:t>
             </a:fld>
             <a:endParaRPr lang="en-US"/>
           </a:p>
@@ -2525,284 +2524,6 @@
   <p:cSld>
     <p:spTree>
       <p:nvGrpSpPr>
-        <p:cNvPr id="1" name=""/>
-        <p:cNvGrpSpPr/>
-        <p:nvPr/>
-      </p:nvGrpSpPr>
-      <p:grpSpPr>
-        <a:xfrm>
-          <a:off x="0" y="0"/>
-          <a:ext cx="0" cy="0"/>
-          <a:chOff x="0" y="0"/>
-          <a:chExt cx="0" cy="0"/>
-        </a:xfrm>
-      </p:grpSpPr>
-      <p:sp>
-        <p:nvSpPr>
-          <p:cNvPr id="4" name="Rectangle 1">
-            <a:extLst>
-              <a:ext uri="{FF2B5EF4-FFF2-40B4-BE49-F238E27FC236}">
-                <a16:creationId xmlns:a16="http://schemas.microsoft.com/office/drawing/2014/main" id="{A00E6664-EB8A-CC00-21CD-1E8D2F1F51B2}"/>
-              </a:ext>
-            </a:extLst>
-          </p:cNvPr>
-          <p:cNvSpPr>
-            <a:spLocks noGrp="1" noChangeArrowheads="1"/>
-          </p:cNvSpPr>
-          <p:nvPr>
-            <p:ph type="body" idx="1"/>
-          </p:nvPr>
-        </p:nvSpPr>
-        <p:spPr bwMode="auto">
-          <a:xfrm>
-            <a:off x="838200" y="1600200"/>
-            <a:ext cx="10515600" cy="4599927"/>
-          </a:xfrm>
-          <a:prstGeom prst="rect">
-            <a:avLst/>
-          </a:prstGeom>
-          <a:noFill/>
-          <a:ln>
-            <a:noFill/>
-          </a:ln>
-          <a:effectLst/>
-          <a:extLst>
-            <a:ext uri="{909E8E84-426E-40DD-AFC4-6F175D3DCCD1}">
-              <a14:hiddenFill xmlns:a14="http://schemas.microsoft.com/office/drawing/2010/main">
-                <a:solidFill>
-                  <a:schemeClr val="accent1"/>
-                </a:solidFill>
-              </a14:hiddenFill>
-            </a:ext>
-            <a:ext uri="{91240B29-F687-4F45-9708-019B960494DF}">
-              <a14:hiddenLine xmlns:a14="http://schemas.microsoft.com/office/drawing/2010/main" w="9525">
-                <a:solidFill>
-                  <a:schemeClr val="tx1"/>
-                </a:solidFill>
-                <a:miter lim="800000"/>
-                <a:headEnd/>
-                <a:tailEnd/>
-              </a14:hiddenLine>
-            </a:ext>
-            <a:ext uri="{AF507438-7753-43E0-B8FC-AC1667EBCBE1}">
-              <a14:hiddenEffects xmlns:a14="http://schemas.microsoft.com/office/drawing/2010/main">
-                <a:effectLst>
-                  <a:outerShdw dist="35921" dir="2700000" algn="ctr" rotWithShape="0">
-                    <a:schemeClr val="bg2"/>
-                  </a:outerShdw>
-                </a:effectLst>
-              </a14:hiddenEffects>
-            </a:ext>
-          </a:extLst>
-        </p:spPr>
-        <p:txBody>
-          <a:bodyPr vert="horz" wrap="square" lIns="91440" tIns="45720" rIns="91440" bIns="158700" numCol="1" anchor="ctr" anchorCtr="0" compatLnSpc="1">
-            <a:prstTxWarp prst="textNoShape">
-              <a:avLst/>
-            </a:prstTxWarp>
-            <a:spAutoFit/>
-          </a:bodyPr>
-          <a:lstStyle/>
-          <a:p>
-            <a:pPr marL="0" marR="0" lvl="0" indent="0" algn="l" defTabSz="914400" rtl="0" eaLnBrk="0" fontAlgn="base" latinLnBrk="0" hangingPunct="0">
-              <a:lnSpc>
-                <a:spcPct val="150000"/>
-              </a:lnSpc>
-              <a:spcBef>
-                <a:spcPct val="0"/>
-              </a:spcBef>
-              <a:spcAft>
-                <a:spcPct val="0"/>
-              </a:spcAft>
-              <a:buClrTx/>
-              <a:buSzTx/>
-              <a:buFontTx/>
-              <a:buNone/>
-              <a:tabLst/>
-            </a:pPr>
-            <a:r>
-              <a:rPr lang="en-TW" altLang="en-TW" sz="2800" dirty="0"/>
-              <a:t>A typical training data pipeline can be framed as an ETL process:</a:t>
-            </a:r>
-          </a:p>
-          <a:p>
-            <a:pPr marL="342900" marR="0" lvl="0" indent="-342900" algn="l" defTabSz="914400" rtl="0" eaLnBrk="0" fontAlgn="base" latinLnBrk="0" hangingPunct="0">
-              <a:lnSpc>
-                <a:spcPct val="150000"/>
-              </a:lnSpc>
-              <a:spcBef>
-                <a:spcPct val="0"/>
-              </a:spcBef>
-              <a:spcAft>
-                <a:spcPct val="0"/>
-              </a:spcAft>
-              <a:buClrTx/>
-              <a:buSzTx/>
-              <a:buFont typeface="Arial" panose="020B0604020202020204" pitchFamily="34" charset="0"/>
-              <a:buChar char="•"/>
-              <a:tabLst/>
-            </a:pPr>
-            <a:r>
-              <a:rPr lang="en-TW" altLang="en-TW" sz="2400" b="1" dirty="0"/>
-              <a:t>Extract</a:t>
-            </a:r>
-            <a:r>
-              <a:rPr lang="en-TW" altLang="en-TW" sz="2400" dirty="0"/>
-              <a:t>: Read data from memory (NumPy) or persistent storage -- either local (HDD/SSD) or remote.</a:t>
-            </a:r>
-          </a:p>
-          <a:p>
-            <a:pPr marL="342900" marR="0" lvl="0" indent="-342900" algn="l" defTabSz="914400" rtl="0" eaLnBrk="0" fontAlgn="base" latinLnBrk="0" hangingPunct="0">
-              <a:lnSpc>
-                <a:spcPct val="150000"/>
-              </a:lnSpc>
-              <a:spcBef>
-                <a:spcPct val="0"/>
-              </a:spcBef>
-              <a:spcAft>
-                <a:spcPct val="0"/>
-              </a:spcAft>
-              <a:buClrTx/>
-              <a:buSzTx/>
-              <a:buFont typeface="Arial" panose="020B0604020202020204" pitchFamily="34" charset="0"/>
-              <a:buChar char="•"/>
-              <a:tabLst/>
-            </a:pPr>
-            <a:r>
-              <a:rPr lang="en-TW" altLang="en-TW" sz="2400" b="1" dirty="0"/>
-              <a:t>Transform</a:t>
-            </a:r>
-            <a:r>
-              <a:rPr lang="en-TW" altLang="en-TW" sz="2400" dirty="0"/>
-              <a:t>: parse and preprocess the data -- shuffling, batching, domain-specific transformations such as image decoding/augmentation.</a:t>
-            </a:r>
-          </a:p>
-          <a:p>
-            <a:pPr marL="342900" marR="0" lvl="0" indent="-342900" algn="l" defTabSz="914400" rtl="0" eaLnBrk="0" fontAlgn="base" latinLnBrk="0" hangingPunct="0">
-              <a:lnSpc>
-                <a:spcPct val="150000"/>
-              </a:lnSpc>
-              <a:spcBef>
-                <a:spcPct val="0"/>
-              </a:spcBef>
-              <a:spcAft>
-                <a:spcPct val="0"/>
-              </a:spcAft>
-              <a:buClrTx/>
-              <a:buSzTx/>
-              <a:buFont typeface="Arial" panose="020B0604020202020204" pitchFamily="34" charset="0"/>
-              <a:buChar char="•"/>
-              <a:tabLst/>
-            </a:pPr>
-            <a:r>
-              <a:rPr lang="en-TW" altLang="en-TW" sz="2400" b="1" dirty="0"/>
-              <a:t>Load</a:t>
-            </a:r>
-            <a:r>
-              <a:rPr lang="en-TW" altLang="en-TW" sz="2400" dirty="0"/>
-              <a:t>: move the transformed data onto the accelerator device(s) that execute the mode</a:t>
-            </a:r>
-          </a:p>
-          <a:p>
-            <a:pPr marL="0" marR="0" lvl="0" indent="0" algn="l" defTabSz="914400" rtl="0" eaLnBrk="0" fontAlgn="base" latinLnBrk="0" hangingPunct="0">
-              <a:lnSpc>
-                <a:spcPct val="100000"/>
-              </a:lnSpc>
-              <a:spcBef>
-                <a:spcPct val="0"/>
-              </a:spcBef>
-              <a:spcAft>
-                <a:spcPct val="0"/>
-              </a:spcAft>
-              <a:buClrTx/>
-              <a:buSzTx/>
-              <a:buFontTx/>
-              <a:buNone/>
-              <a:tabLst/>
-            </a:pPr>
-            <a:endParaRPr lang="en-TW" altLang="en-TW" spc="-10" dirty="0"/>
-          </a:p>
-        </p:txBody>
-      </p:sp>
-      <p:sp>
-        <p:nvSpPr>
-          <p:cNvPr id="5" name="object 2">
-            <a:extLst>
-              <a:ext uri="{FF2B5EF4-FFF2-40B4-BE49-F238E27FC236}">
-                <a16:creationId xmlns:a16="http://schemas.microsoft.com/office/drawing/2014/main" id="{7B27B771-08C5-742A-CDC5-8F1C3A8FD8AC}"/>
-              </a:ext>
-            </a:extLst>
-          </p:cNvPr>
-          <p:cNvSpPr txBox="1">
-            <a:spLocks/>
-          </p:cNvSpPr>
-          <p:nvPr/>
-        </p:nvSpPr>
-        <p:spPr>
-          <a:xfrm>
-            <a:off x="1069975" y="761682"/>
-            <a:ext cx="6547484" cy="701040"/>
-          </a:xfrm>
-          <a:prstGeom prst="rect">
-            <a:avLst/>
-          </a:prstGeom>
-        </p:spPr>
-        <p:txBody>
-          <a:bodyPr vert="horz" wrap="square" lIns="0" tIns="16510" rIns="0" bIns="0" rtlCol="0">
-            <a:spAutoFit/>
-          </a:bodyPr>
-          <a:lstStyle>
-            <a:lvl1pPr>
-              <a:defRPr sz="4400" b="0" i="0">
-                <a:solidFill>
-                  <a:schemeClr val="tx1"/>
-                </a:solidFill>
-                <a:latin typeface="Calibri"/>
-                <a:ea typeface="+mj-ea"/>
-                <a:cs typeface="Calibri"/>
-              </a:defRPr>
-            </a:lvl1pPr>
-          </a:lstStyle>
-          <a:p>
-            <a:pPr marL="12700">
-              <a:spcBef>
-                <a:spcPts val="130"/>
-              </a:spcBef>
-            </a:pPr>
-            <a:r>
-              <a:rPr lang="en-US" dirty="0"/>
-              <a:t>Input</a:t>
-            </a:r>
-            <a:r>
-              <a:rPr lang="en-US" spc="-65" dirty="0"/>
-              <a:t> </a:t>
-            </a:r>
-            <a:r>
-              <a:rPr lang="en-US" dirty="0"/>
-              <a:t>Pipeline</a:t>
-            </a:r>
-            <a:endParaRPr lang="en-US" spc="-10" dirty="0"/>
-          </a:p>
-        </p:txBody>
-      </p:sp>
-    </p:spTree>
-    <p:extLst>
-      <p:ext uri="{BB962C8B-B14F-4D97-AF65-F5344CB8AC3E}">
-        <p14:creationId xmlns:p14="http://schemas.microsoft.com/office/powerpoint/2010/main" val="3723132795"/>
-      </p:ext>
-    </p:extLst>
-  </p:cSld>
-  <p:clrMapOvr>
-    <a:masterClrMapping/>
-  </p:clrMapOvr>
-</p:sld>
-</file>
-
-<file path=ppt/slides/slide11.xml><?xml version="1.0" encoding="utf-8"?>
-<p:sld xmlns:a="http://schemas.openxmlformats.org/drawingml/2006/main" xmlns:r="http://schemas.openxmlformats.org/officeDocument/2006/relationships" xmlns:p="http://schemas.openxmlformats.org/presentationml/2006/main">
-  <p:cSld>
-    <p:spTree>
-      <p:nvGrpSpPr>
         <p:cNvPr id="1" name="">
           <a:extLst>
             <a:ext uri="{FF2B5EF4-FFF2-40B4-BE49-F238E27FC236}">
@@ -3082,7 +2803,7 @@
 </p:sld>
 </file>
 
-<file path=ppt/slides/slide12.xml><?xml version="1.0" encoding="utf-8"?>
+<file path=ppt/slides/slide11.xml><?xml version="1.0" encoding="utf-8"?>
 <p:sld xmlns:a="http://schemas.openxmlformats.org/drawingml/2006/main" xmlns:r="http://schemas.openxmlformats.org/officeDocument/2006/relationships" xmlns:p="http://schemas.openxmlformats.org/presentationml/2006/main">
   <p:cSld>
     <p:spTree>
@@ -3358,7 +3079,7 @@
 </p:sld>
 </file>
 
-<file path=ppt/slides/slide13.xml><?xml version="1.0" encoding="utf-8"?>
+<file path=ppt/slides/slide12.xml><?xml version="1.0" encoding="utf-8"?>
 <p:sld xmlns:a="http://schemas.openxmlformats.org/drawingml/2006/main" xmlns:r="http://schemas.openxmlformats.org/officeDocument/2006/relationships" xmlns:p="http://schemas.openxmlformats.org/presentationml/2006/main" showMasterSp="0">
   <p:cSld>
     <p:spTree>
@@ -4245,7 +3966,7 @@
 </p:sld>
 </file>
 
-<file path=ppt/slides/slide14.xml><?xml version="1.0" encoding="utf-8"?>
+<file path=ppt/slides/slide13.xml><?xml version="1.0" encoding="utf-8"?>
 <p:sld xmlns:a="http://schemas.openxmlformats.org/drawingml/2006/main" xmlns:r="http://schemas.openxmlformats.org/officeDocument/2006/relationships" xmlns:p="http://schemas.openxmlformats.org/presentationml/2006/main">
   <p:cSld>
     <p:spTree>
@@ -4400,8 +4121,8 @@
           </a:p>
         </p:txBody>
       </p:sp>
-      <mc:AlternateContent xmlns:mc="http://schemas.openxmlformats.org/markup-compatibility/2006">
-        <mc:Choice xmlns:p14="http://schemas.microsoft.com/office/powerpoint/2010/main" Requires="p14">
+      <mc:AlternateContent xmlns:mc="http://schemas.openxmlformats.org/markup-compatibility/2006" xmlns:p14="http://schemas.microsoft.com/office/powerpoint/2010/main">
+        <mc:Choice Requires="p14">
           <p:contentPart p14:bwMode="auto" r:id="rId4">
             <p14:nvContentPartPr>
               <p14:cNvPr id="8" name="Ink 7">
@@ -4420,7 +4141,7 @@
             </p14:xfrm>
           </p:contentPart>
         </mc:Choice>
-        <mc:Fallback>
+        <mc:Fallback xmlns="">
           <p:pic>
             <p:nvPicPr>
               <p:cNvPr id="8" name="Ink 7">
@@ -4464,7 +4185,7 @@
 </p:sld>
 </file>
 
-<file path=ppt/slides/slide15.xml><?xml version="1.0" encoding="utf-8"?>
+<file path=ppt/slides/slide14.xml><?xml version="1.0" encoding="utf-8"?>
 <p:sld xmlns:a="http://schemas.openxmlformats.org/drawingml/2006/main" xmlns:r="http://schemas.openxmlformats.org/officeDocument/2006/relationships" xmlns:p="http://schemas.openxmlformats.org/presentationml/2006/main">
   <p:cSld>
     <p:spTree>
@@ -4638,7 +4359,7 @@
 </p:sld>
 </file>
 
-<file path=ppt/slides/slide16.xml><?xml version="1.0" encoding="utf-8"?>
+<file path=ppt/slides/slide15.xml><?xml version="1.0" encoding="utf-8"?>
 <p:sld xmlns:a="http://schemas.openxmlformats.org/drawingml/2006/main" xmlns:r="http://schemas.openxmlformats.org/officeDocument/2006/relationships" xmlns:p="http://schemas.openxmlformats.org/presentationml/2006/main" showMasterSp="0">
   <p:cSld>
     <p:spTree>
@@ -4928,7 +4649,7 @@
 </p:sld>
 </file>
 
-<file path=ppt/slides/slide17.xml><?xml version="1.0" encoding="utf-8"?>
+<file path=ppt/slides/slide16.xml><?xml version="1.0" encoding="utf-8"?>
 <p:sld xmlns:a="http://schemas.openxmlformats.org/drawingml/2006/main" xmlns:r="http://schemas.openxmlformats.org/officeDocument/2006/relationships" xmlns:p="http://schemas.openxmlformats.org/presentationml/2006/main">
   <p:cSld>
     <p:spTree>
@@ -5084,7 +4805,7 @@
 </p:sld>
 </file>
 
-<file path=ppt/slides/slide18.xml><?xml version="1.0" encoding="utf-8"?>
+<file path=ppt/slides/slide17.xml><?xml version="1.0" encoding="utf-8"?>
 <p:sld xmlns:a="http://schemas.openxmlformats.org/drawingml/2006/main" xmlns:r="http://schemas.openxmlformats.org/officeDocument/2006/relationships" xmlns:p="http://schemas.openxmlformats.org/presentationml/2006/main">
   <p:cSld>
     <p:spTree>
@@ -5178,13 +4899,69 @@
           <a:p>
             <a:r>
               <a:rPr lang="en-US" sz="2800" dirty="0"/>
-              <a:t>CPU:  [load 1]          [load 2]          [load 3]</a:t>
-            </a:r>
-          </a:p>
-          <a:p>
+              <a:t>CPU:  [load 1]   </a:t>
+            </a:r>
+            <a:r>
+              <a:rPr lang="zh-TW" altLang="en-US" sz="2800" dirty="0"/>
+              <a:t>  </a:t>
+            </a:r>
             <a:r>
               <a:rPr lang="en-US" sz="2800" dirty="0"/>
-              <a:t>GPU:          [train 1]         [train 2]         [train 3]</a:t>
+              <a:t> </a:t>
+            </a:r>
+            <a:r>
+              <a:rPr lang="zh-TW" altLang="en-US" sz="2800" dirty="0"/>
+              <a:t> </a:t>
+            </a:r>
+            <a:r>
+              <a:rPr lang="en-US" sz="2800" dirty="0"/>
+              <a:t>      [load 2]  </a:t>
+            </a:r>
+            <a:r>
+              <a:rPr lang="zh-TW" altLang="en-US" sz="2800" dirty="0"/>
+              <a:t>   </a:t>
+            </a:r>
+            <a:r>
+              <a:rPr lang="en-US" sz="2800" dirty="0"/>
+              <a:t>     </a:t>
+            </a:r>
+            <a:r>
+              <a:rPr lang="zh-TW" altLang="en-US" sz="2800" dirty="0"/>
+              <a:t> </a:t>
+            </a:r>
+            <a:r>
+              <a:rPr lang="en-US" sz="2800" dirty="0"/>
+              <a:t>   [load 3]</a:t>
+            </a:r>
+          </a:p>
+          <a:p>
+            <a:r>
+              <a:rPr lang="en-US" sz="2800" dirty="0"/>
+              <a:t>GPU:          </a:t>
+            </a:r>
+            <a:r>
+              <a:rPr lang="zh-TW" altLang="en-US" sz="2800" dirty="0"/>
+              <a:t>    </a:t>
+            </a:r>
+            <a:r>
+              <a:rPr lang="en-US" sz="2800" dirty="0"/>
+              <a:t>[train 1]  </a:t>
+            </a:r>
+            <a:r>
+              <a:rPr lang="zh-TW" altLang="en-US" sz="2800" dirty="0"/>
+              <a:t>    </a:t>
+            </a:r>
+            <a:r>
+              <a:rPr lang="en-US" sz="2800" dirty="0"/>
+              <a:t>       [train 2]  </a:t>
+            </a:r>
+            <a:r>
+              <a:rPr lang="zh-TW" altLang="en-US" sz="2800" dirty="0"/>
+              <a:t>     </a:t>
+            </a:r>
+            <a:r>
+              <a:rPr lang="en-US" sz="2800" dirty="0"/>
+              <a:t>       [train 3]</a:t>
             </a:r>
           </a:p>
           <a:p>
@@ -5306,7 +5083,15 @@
           <a:p>
             <a:r>
               <a:rPr lang="en-US" sz="2800" dirty="0"/>
-              <a:t>GPU:          [train 1][train 2][train 3][train 4]</a:t>
+              <a:t>GPU:      </a:t>
+            </a:r>
+            <a:r>
+              <a:rPr lang="zh-TW" altLang="en-US" sz="2800" dirty="0"/>
+              <a:t>      </a:t>
+            </a:r>
+            <a:r>
+              <a:rPr lang="en-US" sz="2800" dirty="0"/>
+              <a:t>    [train 1][train 2][train 3][train 4]</a:t>
             </a:r>
           </a:p>
           <a:p>
@@ -5322,6 +5107,151 @@
     <p:extLst>
       <p:ext uri="{BB962C8B-B14F-4D97-AF65-F5344CB8AC3E}">
         <p14:creationId xmlns:p14="http://schemas.microsoft.com/office/powerpoint/2010/main" val="720955530"/>
+      </p:ext>
+    </p:extLst>
+  </p:cSld>
+  <p:clrMapOvr>
+    <a:masterClrMapping/>
+  </p:clrMapOvr>
+</p:sld>
+</file>
+
+<file path=ppt/slides/slide18.xml><?xml version="1.0" encoding="utf-8"?>
+<p:sld xmlns:a="http://schemas.openxmlformats.org/drawingml/2006/main" xmlns:r="http://schemas.openxmlformats.org/officeDocument/2006/relationships" xmlns:p="http://schemas.openxmlformats.org/presentationml/2006/main">
+  <p:cSld>
+    <p:spTree>
+      <p:nvGrpSpPr>
+        <p:cNvPr id="1" name=""/>
+        <p:cNvGrpSpPr/>
+        <p:nvPr/>
+      </p:nvGrpSpPr>
+      <p:grpSpPr>
+        <a:xfrm>
+          <a:off x="0" y="0"/>
+          <a:ext cx="0" cy="0"/>
+          <a:chOff x="0" y="0"/>
+          <a:chExt cx="0" cy="0"/>
+        </a:xfrm>
+      </p:grpSpPr>
+      <p:sp>
+        <p:nvSpPr>
+          <p:cNvPr id="2" name="Title 1">
+            <a:extLst>
+              <a:ext uri="{FF2B5EF4-FFF2-40B4-BE49-F238E27FC236}">
+                <a16:creationId xmlns:a16="http://schemas.microsoft.com/office/drawing/2014/main" id="{DB88515E-DF91-7C64-0353-2025C507D8CD}"/>
+              </a:ext>
+            </a:extLst>
+          </p:cNvPr>
+          <p:cNvSpPr>
+            <a:spLocks noGrp="1"/>
+          </p:cNvSpPr>
+          <p:nvPr>
+            <p:ph type="title"/>
+          </p:nvPr>
+        </p:nvSpPr>
+        <p:spPr/>
+        <p:txBody>
+          <a:bodyPr/>
+          <a:lstStyle/>
+          <a:p>
+            <a:r>
+              <a:rPr lang="en-US" dirty="0"/>
+              <a:t>Prefetching</a:t>
+            </a:r>
+            <a:endParaRPr lang="en-TW" dirty="0"/>
+          </a:p>
+        </p:txBody>
+      </p:sp>
+      <p:sp>
+        <p:nvSpPr>
+          <p:cNvPr id="3" name="Text Placeholder 2">
+            <a:extLst>
+              <a:ext uri="{FF2B5EF4-FFF2-40B4-BE49-F238E27FC236}">
+                <a16:creationId xmlns:a16="http://schemas.microsoft.com/office/drawing/2014/main" id="{03EBA6DC-554E-FC76-5FC7-99799D1D18A9}"/>
+              </a:ext>
+            </a:extLst>
+          </p:cNvPr>
+          <p:cNvSpPr>
+            <a:spLocks noGrp="1"/>
+          </p:cNvSpPr>
+          <p:nvPr>
+            <p:ph type="body" idx="1"/>
+          </p:nvPr>
+        </p:nvSpPr>
+        <p:spPr>
+          <a:xfrm>
+            <a:off x="917575" y="1754504"/>
+            <a:ext cx="10283825" cy="4457502"/>
+          </a:xfrm>
+        </p:spPr>
+        <p:txBody>
+          <a:bodyPr/>
+          <a:lstStyle/>
+          <a:p>
+            <a:pPr marL="342900" indent="-342900">
+              <a:lnSpc>
+                <a:spcPct val="150000"/>
+              </a:lnSpc>
+              <a:buFont typeface="Arial" panose="020B0604020202020204" pitchFamily="34" charset="0"/>
+              <a:buChar char="•"/>
+            </a:pPr>
+            <a:r>
+              <a:rPr lang="en-US" sz="2800" b="1" dirty="0" err="1"/>
+              <a:t>prefetch_factor</a:t>
+            </a:r>
+            <a:r>
+              <a:rPr lang="en-US" sz="2800" b="1" dirty="0"/>
+              <a:t> </a:t>
+            </a:r>
+            <a:r>
+              <a:rPr lang="en-US" sz="2800" dirty="0"/>
+              <a:t>: The number of batches each worker loads ahead of time.</a:t>
+            </a:r>
+          </a:p>
+          <a:p>
+            <a:pPr marL="342900" indent="-342900">
+              <a:lnSpc>
+                <a:spcPct val="150000"/>
+              </a:lnSpc>
+              <a:buFont typeface="Arial" panose="020B0604020202020204" pitchFamily="34" charset="0"/>
+              <a:buChar char="•"/>
+            </a:pPr>
+            <a:r>
+              <a:rPr lang="en-US" sz="2800" b="1" dirty="0" err="1"/>
+              <a:t>pin_memory</a:t>
+            </a:r>
+            <a:r>
+              <a:rPr lang="en-US" sz="2800" b="1" dirty="0"/>
+              <a:t> </a:t>
+            </a:r>
+            <a:r>
+              <a:rPr lang="en-TW" sz="2800" dirty="0"/>
+              <a:t>: </a:t>
+            </a:r>
+            <a:r>
+              <a:rPr lang="en-US" sz="2800" dirty="0"/>
+              <a:t>The GPU copies data using DMA (direct memory access), which reads RAM without the CPU’s involvement. DMA needs the data to stay at a fixed physical address, so it can only read pinned (page-locked) memory</a:t>
+            </a:r>
+          </a:p>
+          <a:p>
+            <a:pPr marL="342900" indent="-342900">
+              <a:lnSpc>
+                <a:spcPct val="150000"/>
+              </a:lnSpc>
+              <a:buFont typeface="Arial" panose="020B0604020202020204" pitchFamily="34" charset="0"/>
+              <a:buChar char="•"/>
+            </a:pPr>
+            <a:r>
+              <a:rPr lang="en-US" sz="2800" dirty="0"/>
+              <a:t>Note that different batches don’t necessary take same time to fetch</a:t>
+            </a:r>
+          </a:p>
+        </p:txBody>
+      </p:sp>
+    </p:spTree>
+    <p:extLst>
+      <p:ext uri="{BB962C8B-B14F-4D97-AF65-F5344CB8AC3E}">
+        <p14:creationId xmlns:p14="http://schemas.microsoft.com/office/powerpoint/2010/main" val="816914386"/>
       </p:ext>
     </p:extLst>
   </p:cSld>
@@ -5353,7 +5283,7 @@
           <p:cNvPr id="2" name="Title 1">
             <a:extLst>
               <a:ext uri="{FF2B5EF4-FFF2-40B4-BE49-F238E27FC236}">
-                <a16:creationId xmlns:a16="http://schemas.microsoft.com/office/drawing/2014/main" id="{DB88515E-DF91-7C64-0353-2025C507D8CD}"/>
+                <a16:creationId xmlns:a16="http://schemas.microsoft.com/office/drawing/2014/main" id="{36BA55B6-8D68-4F6E-54F6-9BB8738CBC88}"/>
               </a:ext>
             </a:extLst>
           </p:cNvPr>
@@ -5371,9 +5301,12 @@
           <a:p>
             <a:r>
               <a:rPr lang="en-US" dirty="0"/>
-              <a:t>Prefetching</a:t>
-            </a:r>
-            <a:endParaRPr lang="en-TW" dirty="0"/>
+              <a:t>C</a:t>
+            </a:r>
+            <a:r>
+              <a:rPr lang="en-TW" dirty="0"/>
+              <a:t>ache (in Dataset)</a:t>
+            </a:r>
           </a:p>
         </p:txBody>
       </p:sp>
@@ -5382,7 +5315,7 @@
           <p:cNvPr id="3" name="Text Placeholder 2">
             <a:extLst>
               <a:ext uri="{FF2B5EF4-FFF2-40B4-BE49-F238E27FC236}">
-                <a16:creationId xmlns:a16="http://schemas.microsoft.com/office/drawing/2014/main" id="{03EBA6DC-554E-FC76-5FC7-99799D1D18A9}"/>
+                <a16:creationId xmlns:a16="http://schemas.microsoft.com/office/drawing/2014/main" id="{8E3980E2-A644-25AE-DA6F-C333BD480E9C}"/>
               </a:ext>
             </a:extLst>
           </p:cNvPr>
@@ -5395,15 +5328,15 @@
         </p:nvSpPr>
         <p:spPr>
           <a:xfrm>
-            <a:off x="917575" y="1754504"/>
-            <a:ext cx="10283825" cy="4457502"/>
+            <a:off x="917575" y="1600200"/>
+            <a:ext cx="10079355" cy="5012719"/>
           </a:xfrm>
         </p:spPr>
         <p:txBody>
           <a:bodyPr/>
           <a:lstStyle/>
           <a:p>
-            <a:pPr marL="342900" indent="-342900">
+            <a:pPr marL="457200" indent="-457200">
               <a:lnSpc>
                 <a:spcPct val="150000"/>
               </a:lnSpc>
@@ -5411,20 +5344,16 @@
               <a:buChar char="•"/>
             </a:pPr>
             <a:r>
-              <a:rPr lang="en-US" sz="2800" b="1" dirty="0" err="1"/>
-              <a:t>prefetch_factor</a:t>
-            </a:r>
-            <a:r>
-              <a:rPr lang="en-US" sz="2800" b="1" dirty="0"/>
-              <a:t> </a:t>
-            </a:r>
-            <a:r>
-              <a:rPr lang="en-US" sz="2800" dirty="0"/>
-              <a:t>: The number of batches each worker loads ahead of time.</a:t>
-            </a:r>
-          </a:p>
-          <a:p>
-            <a:pPr marL="342900" indent="-342900">
+              <a:rPr lang="en-TW" dirty="0"/>
+              <a:t>We go over the same data every epoch. </a:t>
+            </a:r>
+            <a:r>
+              <a:rPr lang="en-US" dirty="0"/>
+              <a:t>Without caching, each epoch repeats the same work for every image: read the file from disk, decode it, convert it to a tensor.</a:t>
+            </a:r>
+          </a:p>
+          <a:p>
+            <a:pPr marL="457200" indent="-457200">
               <a:lnSpc>
                 <a:spcPct val="150000"/>
               </a:lnSpc>
@@ -5432,24 +5361,12 @@
               <a:buChar char="•"/>
             </a:pPr>
             <a:r>
-              <a:rPr lang="en-US" sz="2800" b="1" dirty="0" err="1"/>
-              <a:t>pin_memory</a:t>
-            </a:r>
-            <a:r>
-              <a:rPr lang="en-US" sz="2800" b="1" dirty="0"/>
-              <a:t> </a:t>
-            </a:r>
-            <a:r>
-              <a:rPr lang="en-TW" sz="2800" dirty="0"/>
-              <a:t>: </a:t>
-            </a:r>
-            <a:r>
-              <a:rPr lang="en-US" sz="2800" dirty="0"/>
-              <a:t>The GPU copies data using DMA (direct memory access), which reads RAM without the CPU’s involvement. DMA needs the data to stay at a fixed physical address, so it can only read pinned (page-locked) memory</a:t>
-            </a:r>
-          </a:p>
-          <a:p>
-            <a:pPr marL="342900" indent="-342900">
+              <a:rPr lang="en-US" dirty="0"/>
+              <a:t>Cache the decoded image, then transform</a:t>
+            </a:r>
+          </a:p>
+          <a:p>
+            <a:pPr marL="457200" indent="-457200">
               <a:lnSpc>
                 <a:spcPct val="150000"/>
               </a:lnSpc>
@@ -5457,16 +5374,42 @@
               <a:buChar char="•"/>
             </a:pPr>
             <a:r>
-              <a:rPr lang="en-US" sz="2800" dirty="0"/>
-              <a:t>Note that different batches don’t necessary take same time to fetch</a:t>
-            </a:r>
+              <a:rPr lang="en-US" dirty="0"/>
+              <a:t>Note that workers restart every epoch, The new workers start from a copy of the dataset in the main process, whose cache is empty.</a:t>
+            </a:r>
+          </a:p>
+          <a:p>
+            <a:pPr marL="457200" indent="-457200">
+              <a:lnSpc>
+                <a:spcPct val="150000"/>
+              </a:lnSpc>
+              <a:buFont typeface="Arial" panose="020B0604020202020204" pitchFamily="34" charset="0"/>
+              <a:buChar char="•"/>
+            </a:pPr>
+            <a:r>
+              <a:rPr lang="en-US" dirty="0"/>
+              <a:t>Even with </a:t>
+            </a:r>
+            <a:r>
+              <a:rPr lang="en-US" b="1" dirty="0" err="1"/>
+              <a:t>persistent_workers</a:t>
+            </a:r>
+            <a:r>
+              <a:rPr lang="en-US" b="1" dirty="0"/>
+              <a:t>=True</a:t>
+            </a:r>
+            <a:r>
+              <a:rPr lang="en-US" dirty="0"/>
+              <a:t>, the caches are split across worker because of shuffle</a:t>
+            </a:r>
+            <a:endParaRPr lang="en-TW" dirty="0"/>
           </a:p>
         </p:txBody>
       </p:sp>
     </p:spTree>
     <p:extLst>
       <p:ext uri="{BB962C8B-B14F-4D97-AF65-F5344CB8AC3E}">
-        <p14:creationId xmlns:p14="http://schemas.microsoft.com/office/powerpoint/2010/main" val="816914386"/>
+        <p14:creationId xmlns:p14="http://schemas.microsoft.com/office/powerpoint/2010/main" val="1123363280"/>
       </p:ext>
     </p:extLst>
   </p:cSld>
@@ -5735,164 +5678,6 @@
         </p:txBody>
       </p:sp>
     </p:spTree>
-  </p:cSld>
-  <p:clrMapOvr>
-    <a:masterClrMapping/>
-  </p:clrMapOvr>
-</p:sld>
-</file>
-
-<file path=ppt/slides/slide20.xml><?xml version="1.0" encoding="utf-8"?>
-<p:sld xmlns:a="http://schemas.openxmlformats.org/drawingml/2006/main" xmlns:r="http://schemas.openxmlformats.org/officeDocument/2006/relationships" xmlns:p="http://schemas.openxmlformats.org/presentationml/2006/main">
-  <p:cSld>
-    <p:spTree>
-      <p:nvGrpSpPr>
-        <p:cNvPr id="1" name=""/>
-        <p:cNvGrpSpPr/>
-        <p:nvPr/>
-      </p:nvGrpSpPr>
-      <p:grpSpPr>
-        <a:xfrm>
-          <a:off x="0" y="0"/>
-          <a:ext cx="0" cy="0"/>
-          <a:chOff x="0" y="0"/>
-          <a:chExt cx="0" cy="0"/>
-        </a:xfrm>
-      </p:grpSpPr>
-      <p:sp>
-        <p:nvSpPr>
-          <p:cNvPr id="2" name="Title 1">
-            <a:extLst>
-              <a:ext uri="{FF2B5EF4-FFF2-40B4-BE49-F238E27FC236}">
-                <a16:creationId xmlns:a16="http://schemas.microsoft.com/office/drawing/2014/main" id="{36BA55B6-8D68-4F6E-54F6-9BB8738CBC88}"/>
-              </a:ext>
-            </a:extLst>
-          </p:cNvPr>
-          <p:cNvSpPr>
-            <a:spLocks noGrp="1"/>
-          </p:cNvSpPr>
-          <p:nvPr>
-            <p:ph type="title"/>
-          </p:nvPr>
-        </p:nvSpPr>
-        <p:spPr/>
-        <p:txBody>
-          <a:bodyPr/>
-          <a:lstStyle/>
-          <a:p>
-            <a:r>
-              <a:rPr lang="en-US" dirty="0"/>
-              <a:t>C</a:t>
-            </a:r>
-            <a:r>
-              <a:rPr lang="en-TW" dirty="0"/>
-              <a:t>ache (in Dataset)</a:t>
-            </a:r>
-          </a:p>
-        </p:txBody>
-      </p:sp>
-      <p:sp>
-        <p:nvSpPr>
-          <p:cNvPr id="3" name="Text Placeholder 2">
-            <a:extLst>
-              <a:ext uri="{FF2B5EF4-FFF2-40B4-BE49-F238E27FC236}">
-                <a16:creationId xmlns:a16="http://schemas.microsoft.com/office/drawing/2014/main" id="{8E3980E2-A644-25AE-DA6F-C333BD480E9C}"/>
-              </a:ext>
-            </a:extLst>
-          </p:cNvPr>
-          <p:cNvSpPr>
-            <a:spLocks noGrp="1"/>
-          </p:cNvSpPr>
-          <p:nvPr>
-            <p:ph type="body" idx="1"/>
-          </p:nvPr>
-        </p:nvSpPr>
-        <p:spPr>
-          <a:xfrm>
-            <a:off x="917575" y="1600200"/>
-            <a:ext cx="10079355" cy="5012719"/>
-          </a:xfrm>
-        </p:spPr>
-        <p:txBody>
-          <a:bodyPr/>
-          <a:lstStyle/>
-          <a:p>
-            <a:pPr marL="457200" indent="-457200">
-              <a:lnSpc>
-                <a:spcPct val="150000"/>
-              </a:lnSpc>
-              <a:buFont typeface="Arial" panose="020B0604020202020204" pitchFamily="34" charset="0"/>
-              <a:buChar char="•"/>
-            </a:pPr>
-            <a:r>
-              <a:rPr lang="en-TW" dirty="0"/>
-              <a:t>We go over the same data every epoch. </a:t>
-            </a:r>
-            <a:r>
-              <a:rPr lang="en-US" dirty="0"/>
-              <a:t>Without caching, each epoch repeats the same work for every image: read the file from disk, decode it, convert it to a tensor.</a:t>
-            </a:r>
-          </a:p>
-          <a:p>
-            <a:pPr marL="457200" indent="-457200">
-              <a:lnSpc>
-                <a:spcPct val="150000"/>
-              </a:lnSpc>
-              <a:buFont typeface="Arial" panose="020B0604020202020204" pitchFamily="34" charset="0"/>
-              <a:buChar char="•"/>
-            </a:pPr>
-            <a:r>
-              <a:rPr lang="en-US" dirty="0"/>
-              <a:t>Cache the decoded image, then transform</a:t>
-            </a:r>
-          </a:p>
-          <a:p>
-            <a:pPr marL="457200" indent="-457200">
-              <a:lnSpc>
-                <a:spcPct val="150000"/>
-              </a:lnSpc>
-              <a:buFont typeface="Arial" panose="020B0604020202020204" pitchFamily="34" charset="0"/>
-              <a:buChar char="•"/>
-            </a:pPr>
-            <a:r>
-              <a:rPr lang="en-US" dirty="0"/>
-              <a:t>Note that workers restart every epoch, The new workers start from a copy of the dataset in the main process, whose cache is empty.</a:t>
-            </a:r>
-          </a:p>
-          <a:p>
-            <a:pPr marL="457200" indent="-457200">
-              <a:lnSpc>
-                <a:spcPct val="150000"/>
-              </a:lnSpc>
-              <a:buFont typeface="Arial" panose="020B0604020202020204" pitchFamily="34" charset="0"/>
-              <a:buChar char="•"/>
-            </a:pPr>
-            <a:r>
-              <a:rPr lang="en-US" dirty="0"/>
-              <a:t>Even with </a:t>
-            </a:r>
-            <a:r>
-              <a:rPr lang="en-US" b="1" dirty="0" err="1"/>
-              <a:t>persistent_workers</a:t>
-            </a:r>
-            <a:r>
-              <a:rPr lang="en-US" b="1" dirty="0"/>
-              <a:t>=True</a:t>
-            </a:r>
-            <a:r>
-              <a:rPr lang="en-US" dirty="0"/>
-              <a:t>, the caches are split across worker because of shuffle</a:t>
-            </a:r>
-            <a:endParaRPr lang="en-TW" dirty="0"/>
-          </a:p>
-        </p:txBody>
-      </p:sp>
-    </p:spTree>
-    <p:extLst>
-      <p:ext uri="{BB962C8B-B14F-4D97-AF65-F5344CB8AC3E}">
-        <p14:creationId xmlns:p14="http://schemas.microsoft.com/office/powerpoint/2010/main" val="1123363280"/>
-      </p:ext>
-    </p:extLst>
   </p:cSld>
   <p:clrMapOvr>
     <a:masterClrMapping/>

</xml_diff>